<commit_message>
Update presentation materials and technical report with new findings and error handling
- Revised PDF and PPTX presentations to include updated information on API errors and performance metrics.
- Enhanced presentation notes to reflect manual run observations and HTTP 429 errors encountered during testing.
- Updated technical report to document repeated HTTP 429 responses from Semantic Scholar and OpenAlex, including implications for evidence retrieval.
- Adjusted LaTeX report to clarify limitations and provide a minimal reproduction command for benchmarks.
- Improved Python scripts for presentation generation to align with updated content.
- Added new dependencies for development and adjusted existing ones for compatibility with the latest libraries.
- Enhanced test cases to verify prompt formatting in backend responses.
</commit_message>
<xml_diff>
--- a/CapStone Project/docs/presentation/ClaimGuard_Capstone_Praesentation_DE_mit_UI_Demo.pptx
+++ b/CapStone Project/docs/presentation/ClaimGuard_Capstone_Praesentation_DE_mit_UI_Demo.pptx
@@ -226,7 +226,7 @@
               </c14:invertSolidFillFmt>
             </c:ext>
             <c:ext xmlns:c16="http://schemas.microsoft.com/office/drawing/2014/chart" uri="{C3380CC4-5D6E-409C-BE32-E72D297353CC}">
-              <c16:uniqueId val="{00000000-F590-4043-A819-D8EB46FE0335}"/>
+              <c16:uniqueId val="{00000000-DDB1-493C-A613-DBA10119FB43}"/>
             </c:ext>
           </c:extLst>
         </c:ser>
@@ -345,7 +345,7 @@
     </p:spTree>
     <p:extLst>
       <p:ext uri="{BB962C8B-B14F-4D97-AF65-F5344CB8AC3E}">
-        <p14:creationId xmlns:p14="http://schemas.microsoft.com/office/powerpoint/2010/main" val="4196801629"/>
+        <p14:creationId xmlns:p14="http://schemas.microsoft.com/office/powerpoint/2010/main" val="3867626645"/>
       </p:ext>
     </p:extLst>
   </p:cSld>
@@ -570,7 +570,7 @@
           </a:p>
           <a:p>
             <a:r>
-              <a:t>Je zwei konkrete Stärken und Schwächen nennen. Fast-DetectGPT erzeugte in diesem kleinen Set keinen menschlichen Fehlalarm, übersah aber 7 von 15 generierten Texten. Der offizielle Datensatz enthält keine Zitiermarker; eine Korrelation wird daher nicht behauptet. Private Berichte wurden nicht an den externen Detektor gesendet.</a:t>
+              <a:t>Je zwei konkrete Stärken und Schwächen nennen. In manuellen Läufen am 7. Juli 2026 lieferten Semantic-Scholar-Anfragen ohne API-Key und OpenAlex-Anfragen mit konfiguriertem mailto-Parameter wiederholt HTTP 429, auch nach mehreren Minuten Wartezeit und mit einer neuen Eingabedatei. Das ist eine beobachtete Dienstbedingung und kein systematischer API-Verfügbarkeitsbenchmark; fehlende Abstract- oder Volltextevidenz kann dadurch zu unzureichender Evidenz führen. Fast-DetectGPT erzeugte in diesem kleinen Set keinen menschlichen Fehlalarm, übersah aber 7 von 15 generierten Texten. Der offizielle Datensatz enthält keine Zitiermarker; eine Korrelation wird daher nicht behauptet. Private Berichte wurden nicht an den externen Detektor gesendet.</a:t>
             </a:r>
           </a:p>
         </p:txBody>
@@ -1166,8 +1166,13 @@
           <a:p>
             <a:r>
               <a:rPr lang="de-DE"/>
-              <a:t>Nick â€” 45 Sekunden
-Das Video startet automatisch. Zuerst wird der echte RQ5-Bericht hochgeladen und lokal analysiert. Im Ãœberblick nur kurz auf PrÃ¼fbedarf und die methodenunabhÃ¤ngigen Dokumentkennzahlen zeigen. Danach wechselt die Demo in den Modellvergleich: Heuristik und Ollama erhalten dieselben Claims und dieselbe Evidenz. Abweichungen sind kein automatischer Fehlernachweis, sondern gezielte Stellen fÃ¼r die menschliche PrÃ¼fung. Falls das Video nicht startet, das beiliegende ClaimGuard_UI_Demo.mp4 Ã¶ffnen oder die statische Originalfolie verwenden.</a:t>
+              <a:t>Nick â€” 45 Sekunden</a:t>
+            </a:r>
+          </a:p>
+          <a:p>
+            <a:r>
+              <a:rPr lang="de-DE"/>
+              <a:t>Das Video startet automatisch. Zuerst wird der echte RQ5-Bericht hochgeladen und lokal analysiert. Im Ãœberblick nur kurz auf PrÃ¼fbedarf und die methodenunabhÃ¤ngigen Dokumentkennzahlen zeigen. Danach wechselt die Demo in den Modellvergleich: Heuristik und Ollama erhalten dieselben Claims und dieselbe Evidenz. Abweichungen sind kein automatischer Fehlernachweis, sondern gezielte Stellen fÃ¼r die menschliche PrÃ¼fung. Falls das Video nicht startet, das beiliegende ClaimGuard_UI_Demo.mp4 Ã¶ffnen oder die statische Originalfolie verwenden.</a:t>
             </a:r>
             <a:endParaRPr/>
           </a:p>
@@ -5396,7 +5401,7 @@
               </a:defRPr>
             </a:pPr>
             <a:r>
-              <a:t>•  Metadaten-APIs können ausfallen oder drosseln</a:t>
+              <a:t>•  Wiederholte S2/OpenAlex-HTTP-429-Fehler in manuellen Läufen</a:t>
             </a:r>
           </a:p>
           <a:p>
@@ -14214,7 +14219,7 @@
             <a:hlinkClick r:id="" action="ppaction://media"/>
             <a:extLst>
               <a:ext uri="{FF2B5EF4-FFF2-40B4-BE49-F238E27FC236}">
-                <a16:creationId xmlns:a16="http://schemas.microsoft.com/office/drawing/2014/main" id="{4095C825-6432-A79D-211C-786110950796}"/>
+                <a16:creationId xmlns:a16="http://schemas.microsoft.com/office/drawing/2014/main" id="{9418864E-133A-8CE2-F429-0D9595AAAB74}"/>
               </a:ext>
             </a:extLst>
           </p:cNvPr>
@@ -14251,7 +14256,7 @@
           <p:cNvPr id="35" name="Rechteck: abgerundete Ecken 34">
             <a:extLst>
               <a:ext uri="{FF2B5EF4-FFF2-40B4-BE49-F238E27FC236}">
-                <a16:creationId xmlns:a16="http://schemas.microsoft.com/office/drawing/2014/main" id="{9A446823-4E72-CA58-2A74-346D6842A830}"/>
+                <a16:creationId xmlns:a16="http://schemas.microsoft.com/office/drawing/2014/main" id="{58553123-E3DE-95E5-7B12-9C30B14FE8C8}"/>
               </a:ext>
             </a:extLst>
           </p:cNvPr>

</xml_diff>